<commit_message>
ODEB LONODJI : la devise « Unité • Solidarité • Développement » dans les logos
La devise retenue par le bureau exécutif le 18 septembre 2026 remplace, dans
les logos complets de l'ODEB (horizontal, vertical, clairs, superposables),
les bannières, la planche, le papier à en-tête, le modèle de diaporama, le kit
ZIP, la présentation à l'assemblée et la charte, la phrase « Sur les traces de
nos ancêtres, bâtissons notre avenir », qui reste le sens de l'emblème (note
datée sur /odeb et /odeb/identite). Les fichiers d'ADEB LONODJI ne changent pas.

Co-Authored-By: Claude Opus 5.5 <noreply@anthropic.com>
Claude-Session: https://claude.ai/code/session_01Fecvx1RJXf8AiWMrirT6WL
</commit_message>
<xml_diff>
--- a/public/odeb/identite/modele-diaporama-odeb-lonodji.pptx
+++ b/public/odeb/identite/modele-diaporama-odeb-lonodji.pptx
@@ -2476,7 +2476,7 @@
         <p:spPr>
           <a:xfrm>
             <a:off x="1417320" y="1984248"/>
-            <a:ext cx="2372258" cy="548640"/>
+            <a:ext cx="2463698" cy="548640"/>
           </a:xfrm>
           <a:prstGeom prst="rect">
             <a:avLst/>
@@ -2703,7 +2703,7 @@
         <p:spPr>
           <a:xfrm>
             <a:off x="5206898" y="1984248"/>
-            <a:ext cx="2372258" cy="548640"/>
+            <a:ext cx="2463698" cy="548640"/>
           </a:xfrm>
           <a:prstGeom prst="rect">
             <a:avLst/>
@@ -2930,7 +2930,7 @@
         <p:spPr>
           <a:xfrm>
             <a:off x="8996477" y="1984248"/>
-            <a:ext cx="2372258" cy="548640"/>
+            <a:ext cx="2463698" cy="548640"/>
           </a:xfrm>
           <a:prstGeom prst="rect">
             <a:avLst/>
@@ -4569,7 +4569,7 @@
                 <a:ea typeface="Playfair Display" pitchFamily="34" charset="-122"/>
                 <a:cs typeface="Playfair Display" pitchFamily="34" charset="-120"/>
               </a:rPr>
-              <a:t>Sur les traces de nos ancêtres, bâtissons notre avenir.</a:t>
+              <a:t>Unité • Solidarité • Développement</a:t>
             </a:r>
             <a:endParaRPr lang="en-US" sz="3000" dirty="0"/>
           </a:p>

</xml_diff>